<commit_message>
Update dataset attribution and documentation
</commit_message>
<xml_diff>
--- a/docs/Pulmira_Presentation.pptx
+++ b/docs/Pulmira_Presentation.pptx
@@ -2,23 +2,23 @@
 <file path=ppt/presentation.xml><?xml version="1.0" encoding="utf-8"?>
 <p:presentation xmlns:p="http://schemas.openxmlformats.org/presentationml/2006/main">
   <p:sldMasterIdLst>
-    <p:sldMasterId xmlns:r="http://schemas.openxmlformats.org/officeDocument/2006/relationships" id="2147483648" r:id="R5449ba2f489b49bb"/>
+    <p:sldMasterId xmlns:r="http://schemas.openxmlformats.org/officeDocument/2006/relationships" id="2147483648" r:id="R9e6d73570de348c2"/>
   </p:sldMasterIdLst>
   <p:notesMasterIdLst>
-    <p:notesMasterId xmlns:r="http://schemas.openxmlformats.org/officeDocument/2006/relationships" r:id="Re0dc4c3bb387497d"/>
+    <p:notesMasterId xmlns:r="http://schemas.openxmlformats.org/officeDocument/2006/relationships" r:id="R689081d3da8a4b27"/>
   </p:notesMasterIdLst>
   <p:sldIdLst>
-    <p:sldId xmlns:r="http://schemas.openxmlformats.org/officeDocument/2006/relationships" id="256" r:id="Rfcd085693c9347e8"/>
-    <p:sldId xmlns:r="http://schemas.openxmlformats.org/officeDocument/2006/relationships" id="257" r:id="R1056cbe95ccb4a0b"/>
-    <p:sldId xmlns:r="http://schemas.openxmlformats.org/officeDocument/2006/relationships" id="258" r:id="R30186f7c44084a80"/>
-    <p:sldId xmlns:r="http://schemas.openxmlformats.org/officeDocument/2006/relationships" id="259" r:id="Rd3bcc177706949c6"/>
-    <p:sldId xmlns:r="http://schemas.openxmlformats.org/officeDocument/2006/relationships" id="260" r:id="R5d9bb055f36c4d80"/>
-    <p:sldId xmlns:r="http://schemas.openxmlformats.org/officeDocument/2006/relationships" id="261" r:id="R0384bb6c8f9e4e03"/>
-    <p:sldId xmlns:r="http://schemas.openxmlformats.org/officeDocument/2006/relationships" id="262" r:id="R40fe2ab802384aad"/>
-    <p:sldId xmlns:r="http://schemas.openxmlformats.org/officeDocument/2006/relationships" id="263" r:id="Re0470556f9aa4981"/>
-    <p:sldId xmlns:r="http://schemas.openxmlformats.org/officeDocument/2006/relationships" id="264" r:id="Rb48aff04e37d4b90"/>
-    <p:sldId xmlns:r="http://schemas.openxmlformats.org/officeDocument/2006/relationships" id="265" r:id="R4d34130b65274890"/>
-    <p:sldId xmlns:r="http://schemas.openxmlformats.org/officeDocument/2006/relationships" id="266" r:id="Reafeaccf592449f2"/>
+    <p:sldId xmlns:r="http://schemas.openxmlformats.org/officeDocument/2006/relationships" id="256" r:id="R11a3fc3aaa4f483f"/>
+    <p:sldId xmlns:r="http://schemas.openxmlformats.org/officeDocument/2006/relationships" id="257" r:id="Rdce3602108a64a36"/>
+    <p:sldId xmlns:r="http://schemas.openxmlformats.org/officeDocument/2006/relationships" id="258" r:id="R19436f58861344c6"/>
+    <p:sldId xmlns:r="http://schemas.openxmlformats.org/officeDocument/2006/relationships" id="259" r:id="R310a90be71704898"/>
+    <p:sldId xmlns:r="http://schemas.openxmlformats.org/officeDocument/2006/relationships" id="260" r:id="R5541b4e1d68848d0"/>
+    <p:sldId xmlns:r="http://schemas.openxmlformats.org/officeDocument/2006/relationships" id="261" r:id="Rd39939e73b0a4170"/>
+    <p:sldId xmlns:r="http://schemas.openxmlformats.org/officeDocument/2006/relationships" id="262" r:id="R21b20ca598f245dd"/>
+    <p:sldId xmlns:r="http://schemas.openxmlformats.org/officeDocument/2006/relationships" id="263" r:id="R25924ad3503e49a1"/>
+    <p:sldId xmlns:r="http://schemas.openxmlformats.org/officeDocument/2006/relationships" id="264" r:id="R25803cd6d515447f"/>
+    <p:sldId xmlns:r="http://schemas.openxmlformats.org/officeDocument/2006/relationships" id="265" r:id="R5d24c8bc2b33429d"/>
+    <p:sldId xmlns:r="http://schemas.openxmlformats.org/officeDocument/2006/relationships" id="266" r:id="Rfe9bb11504b04e3e"/>
   </p:sldIdLst>
   <p:sldSz cx="12192000" cy="6858000"/>
   <p:notesSz cx="6858000" cy="9144000"/>
@@ -518,7 +518,7 @@
           <a:lstStyle xmlns:a="http://schemas.openxmlformats.org/drawingml/2006/main"/>
           <a:p xmlns:a="http://schemas.openxmlformats.org/drawingml/2006/main">
             <a:r>
-              <a:t>Project sources: README.md; backend/app/main.py, store.py, outlook7.py, simulator.py, forecast24.py; backend/vendor/forecast24/manifest.json; research/reports/forecast24_v1/MODEL_CARD.md. All ML metrics describe a synthetic study. Seven-day points are unvalidated, never exacerbation probability. See THIRD_PARTY_NOTICES.md for unresolved data/artwork rights. The public export excludes real-person records. The diagram summarizes separate component flows; the standalone architecture PDF shows exact API boundaries.</a:t>
+              <a:t>Project sources: README.md; backend/app/main.py, store.py, outlook7.py, simulator.py, forecast24.py; backend/vendor/forecast24/manifest.json; research/reports/forecast24_v1/MODEL_CARD.md. All ML metrics describe a synthetic study. Seven-day points are unvalidated, never exacerbation probability. See THIRD_PARTY_NOTICES.md for the verified Apache-2.0 dataset source and pending artwork rights. The public export excludes real-person records. The diagram summarizes separate component flows; the standalone architecture PDF shows exact API boundaries.</a:t>
             </a:r>
           </a:p>
         </p:txBody>
@@ -588,7 +588,7 @@
           <a:lstStyle xmlns:a="http://schemas.openxmlformats.org/drawingml/2006/main"/>
           <a:p xmlns:a="http://schemas.openxmlformats.org/drawingml/2006/main">
             <a:r>
-              <a:t>Project sources: README.md; backend/app/main.py, store.py, outlook7.py, simulator.py, forecast24.py; backend/vendor/forecast24/manifest.json; research/reports/forecast24_v1/MODEL_CARD.md. All ML metrics describe a synthetic study. Seven-day points are unvalidated, never exacerbation probability. See THIRD_PARTY_NOTICES.md for unresolved data/artwork rights. The public export excludes real-person records. The diagram summarizes separate component flows; the standalone architecture PDF shows exact API boundaries.</a:t>
+              <a:t>Project sources: README.md; backend/app/main.py, store.py, outlook7.py, simulator.py, forecast24.py; backend/vendor/forecast24/manifest.json; research/reports/forecast24_v1/MODEL_CARD.md. All ML metrics describe a synthetic study. Seven-day points are unvalidated, never exacerbation probability. See THIRD_PARTY_NOTICES.md for the verified Apache-2.0 dataset source and pending artwork rights. The public export excludes real-person records. The diagram summarizes separate component flows; the standalone architecture PDF shows exact API boundaries.</a:t>
             </a:r>
           </a:p>
         </p:txBody>
@@ -658,7 +658,7 @@
           <a:lstStyle xmlns:a="http://schemas.openxmlformats.org/drawingml/2006/main"/>
           <a:p xmlns:a="http://schemas.openxmlformats.org/drawingml/2006/main">
             <a:r>
-              <a:t>Project sources: README.md; backend/app/main.py, store.py, outlook7.py, simulator.py, forecast24.py; backend/vendor/forecast24/manifest.json; research/reports/forecast24_v1/MODEL_CARD.md. All ML metrics describe a synthetic study. Seven-day points are unvalidated, never exacerbation probability. See THIRD_PARTY_NOTICES.md for unresolved data/artwork rights. The public export excludes real-person records. The diagram summarizes separate component flows; the standalone architecture PDF shows exact API boundaries.</a:t>
+              <a:t>Project sources: README.md; backend/app/main.py, store.py, outlook7.py, simulator.py, forecast24.py; backend/vendor/forecast24/manifest.json; research/reports/forecast24_v1/MODEL_CARD.md. All ML metrics describe a synthetic study. Seven-day points are unvalidated, never exacerbation probability. See THIRD_PARTY_NOTICES.md for the verified Apache-2.0 dataset source and pending artwork rights. The public export excludes real-person records. The diagram summarizes separate component flows; the standalone architecture PDF shows exact API boundaries.</a:t>
             </a:r>
           </a:p>
         </p:txBody>
@@ -728,7 +728,7 @@
           <a:lstStyle xmlns:a="http://schemas.openxmlformats.org/drawingml/2006/main"/>
           <a:p xmlns:a="http://schemas.openxmlformats.org/drawingml/2006/main">
             <a:r>
-              <a:t>Project sources: README.md; backend/app/main.py, store.py, outlook7.py, simulator.py, forecast24.py; backend/vendor/forecast24/manifest.json; research/reports/forecast24_v1/MODEL_CARD.md. All ML metrics describe a synthetic study. Seven-day points are unvalidated, never exacerbation probability. See THIRD_PARTY_NOTICES.md for unresolved data/artwork rights. The public export excludes real-person records. The diagram summarizes separate component flows; the standalone architecture PDF shows exact API boundaries.</a:t>
+              <a:t>Project sources: README.md; backend/app/main.py, store.py, outlook7.py, simulator.py, forecast24.py; backend/vendor/forecast24/manifest.json; research/reports/forecast24_v1/MODEL_CARD.md. All ML metrics describe a synthetic study. Seven-day points are unvalidated, never exacerbation probability. See THIRD_PARTY_NOTICES.md for the verified Apache-2.0 dataset source and pending artwork rights. The public export excludes real-person records. The diagram summarizes separate component flows; the standalone architecture PDF shows exact API boundaries.</a:t>
             </a:r>
           </a:p>
         </p:txBody>
@@ -798,7 +798,7 @@
           <a:lstStyle xmlns:a="http://schemas.openxmlformats.org/drawingml/2006/main"/>
           <a:p xmlns:a="http://schemas.openxmlformats.org/drawingml/2006/main">
             <a:r>
-              <a:t>Project sources: README.md; backend/app/main.py, store.py, outlook7.py, simulator.py, forecast24.py; backend/vendor/forecast24/manifest.json; research/reports/forecast24_v1/MODEL_CARD.md. All ML metrics describe a synthetic study. Seven-day points are unvalidated, never exacerbation probability. See THIRD_PARTY_NOTICES.md for unresolved data/artwork rights. The public export excludes real-person records. The diagram summarizes separate component flows; the standalone architecture PDF shows exact API boundaries.</a:t>
+              <a:t>Project sources: README.md; backend/app/main.py, store.py, outlook7.py, simulator.py, forecast24.py; backend/vendor/forecast24/manifest.json; research/reports/forecast24_v1/MODEL_CARD.md. All ML metrics describe a synthetic study. Seven-day points are unvalidated, never exacerbation probability. See THIRD_PARTY_NOTICES.md for the verified Apache-2.0 dataset source and pending artwork rights. The public export excludes real-person records. The diagram summarizes separate component flows; the standalone architecture PDF shows exact API boundaries.</a:t>
             </a:r>
           </a:p>
         </p:txBody>
@@ -868,7 +868,7 @@
           <a:lstStyle xmlns:a="http://schemas.openxmlformats.org/drawingml/2006/main"/>
           <a:p xmlns:a="http://schemas.openxmlformats.org/drawingml/2006/main">
             <a:r>
-              <a:t>Project sources: README.md; backend/app/main.py, store.py, outlook7.py, simulator.py, forecast24.py; backend/vendor/forecast24/manifest.json; research/reports/forecast24_v1/MODEL_CARD.md. All ML metrics describe a synthetic study. Seven-day points are unvalidated, never exacerbation probability. See THIRD_PARTY_NOTICES.md for unresolved data/artwork rights. The public export excludes real-person records. The diagram summarizes separate component flows; the standalone architecture PDF shows exact API boundaries.</a:t>
+              <a:t>Project sources: README.md; backend/app/main.py, store.py, outlook7.py, simulator.py, forecast24.py; backend/vendor/forecast24/manifest.json; research/reports/forecast24_v1/MODEL_CARD.md. All ML metrics describe a synthetic study. Seven-day points are unvalidated, never exacerbation probability. See THIRD_PARTY_NOTICES.md for the verified Apache-2.0 dataset source and pending artwork rights. The public export excludes real-person records. The diagram summarizes separate component flows; the standalone architecture PDF shows exact API boundaries.</a:t>
             </a:r>
           </a:p>
         </p:txBody>
@@ -938,7 +938,7 @@
           <a:lstStyle xmlns:a="http://schemas.openxmlformats.org/drawingml/2006/main"/>
           <a:p xmlns:a="http://schemas.openxmlformats.org/drawingml/2006/main">
             <a:r>
-              <a:t>Project sources: README.md; backend/app/main.py, store.py, outlook7.py, simulator.py, forecast24.py; backend/vendor/forecast24/manifest.json; research/reports/forecast24_v1/MODEL_CARD.md. All ML metrics describe a synthetic study. Seven-day points are unvalidated, never exacerbation probability. See THIRD_PARTY_NOTICES.md for unresolved data/artwork rights. The public export excludes real-person records. The diagram summarizes separate component flows; the standalone architecture PDF shows exact API boundaries.</a:t>
+              <a:t>Project sources: README.md; backend/app/main.py, store.py, outlook7.py, simulator.py, forecast24.py; backend/vendor/forecast24/manifest.json; research/reports/forecast24_v1/MODEL_CARD.md. All ML metrics describe a synthetic study. Seven-day points are unvalidated, never exacerbation probability. See THIRD_PARTY_NOTICES.md for the verified Apache-2.0 dataset source and pending artwork rights. The public export excludes real-person records. The diagram summarizes separate component flows; the standalone architecture PDF shows exact API boundaries.</a:t>
             </a:r>
           </a:p>
         </p:txBody>
@@ -1008,7 +1008,7 @@
           <a:lstStyle xmlns:a="http://schemas.openxmlformats.org/drawingml/2006/main"/>
           <a:p xmlns:a="http://schemas.openxmlformats.org/drawingml/2006/main">
             <a:r>
-              <a:t>Project sources: README.md; backend/app/main.py, store.py, outlook7.py, simulator.py, forecast24.py; backend/vendor/forecast24/manifest.json; research/reports/forecast24_v1/MODEL_CARD.md. All ML metrics describe a synthetic study. Seven-day points are unvalidated, never exacerbation probability. See THIRD_PARTY_NOTICES.md for unresolved data/artwork rights. The public export excludes real-person records. The diagram summarizes separate component flows; the standalone architecture PDF shows exact API boundaries.</a:t>
+              <a:t>Project sources: README.md; backend/app/main.py, store.py, outlook7.py, simulator.py, forecast24.py; backend/vendor/forecast24/manifest.json; research/reports/forecast24_v1/MODEL_CARD.md. All ML metrics describe a synthetic study. Seven-day points are unvalidated, never exacerbation probability. See THIRD_PARTY_NOTICES.md for the verified Apache-2.0 dataset source and pending artwork rights. The public export excludes real-person records. The diagram summarizes separate component flows; the standalone architecture PDF shows exact API boundaries.</a:t>
             </a:r>
           </a:p>
         </p:txBody>
@@ -1078,7 +1078,7 @@
           <a:lstStyle xmlns:a="http://schemas.openxmlformats.org/drawingml/2006/main"/>
           <a:p xmlns:a="http://schemas.openxmlformats.org/drawingml/2006/main">
             <a:r>
-              <a:t>Project sources: README.md; backend/app/main.py, store.py, outlook7.py, simulator.py, forecast24.py; backend/vendor/forecast24/manifest.json; research/reports/forecast24_v1/MODEL_CARD.md. All ML metrics describe a synthetic study. Seven-day points are unvalidated, never exacerbation probability. See THIRD_PARTY_NOTICES.md for unresolved data/artwork rights. The public export excludes real-person records. The diagram summarizes separate component flows; the standalone architecture PDF shows exact API boundaries.</a:t>
+              <a:t>Project sources: README.md; backend/app/main.py, store.py, outlook7.py, simulator.py, forecast24.py; backend/vendor/forecast24/manifest.json; research/reports/forecast24_v1/MODEL_CARD.md. All ML metrics describe a synthetic study. Seven-day points are unvalidated, never exacerbation probability. See THIRD_PARTY_NOTICES.md for the verified Apache-2.0 dataset source and pending artwork rights. The public export excludes real-person records. The diagram summarizes separate component flows; the standalone architecture PDF shows exact API boundaries.</a:t>
             </a:r>
           </a:p>
         </p:txBody>
@@ -1148,7 +1148,7 @@
           <a:lstStyle xmlns:a="http://schemas.openxmlformats.org/drawingml/2006/main"/>
           <a:p xmlns:a="http://schemas.openxmlformats.org/drawingml/2006/main">
             <a:r>
-              <a:t>Project sources: README.md; backend/app/main.py, store.py, outlook7.py, simulator.py, forecast24.py; backend/vendor/forecast24/manifest.json; research/reports/forecast24_v1/MODEL_CARD.md. All ML metrics describe a synthetic study. Seven-day points are unvalidated, never exacerbation probability. See THIRD_PARTY_NOTICES.md for unresolved data/artwork rights. The public export excludes real-person records. The diagram summarizes separate component flows; the standalone architecture PDF shows exact API boundaries.</a:t>
+              <a:t>Project sources: README.md; backend/app/main.py, store.py, outlook7.py, simulator.py, forecast24.py; backend/vendor/forecast24/manifest.json; research/reports/forecast24_v1/MODEL_CARD.md. All ML metrics describe a synthetic study. Seven-day points are unvalidated, never exacerbation probability. See THIRD_PARTY_NOTICES.md for the verified Apache-2.0 dataset source and pending artwork rights. The public export excludes real-person records. The diagram summarizes separate component flows; the standalone architecture PDF shows exact API boundaries.</a:t>
             </a:r>
           </a:p>
         </p:txBody>
@@ -1195,7 +1195,7 @@
           <p:cNvPr id="3" name="Title">
             <a:extLst xmlns:a="http://schemas.openxmlformats.org/drawingml/2006/main">
               <a:ext uri="{FF2B5EF4-FFF2-40B4-BE49-F238E27FC236}">
-                <a16:creationId xmlns:a16="http://schemas.microsoft.com/office/drawing/2014/main" id="{3494B6C6-FDB2-43CE-8274-88FCACA162D3}"/>
+                <a16:creationId xmlns:a16="http://schemas.microsoft.com/office/drawing/2014/main" id="{C198EC35-B07C-41E5-B9BB-33CA4896118A}"/>
               </a:ext>
             </a:extLst>
           </p:cNvPr>
@@ -1424,7 +1424,7 @@
           <p:cNvPr id="2" name="Subtitle">
             <a:extLst xmlns:a="http://schemas.openxmlformats.org/drawingml/2006/main">
               <a:ext uri="{FF2B5EF4-FFF2-40B4-BE49-F238E27FC236}">
-                <a16:creationId xmlns:a16="http://schemas.microsoft.com/office/drawing/2014/main" id="{E38521E2-1905-4699-9FA0-54E299DA6C91}"/>
+                <a16:creationId xmlns:a16="http://schemas.microsoft.com/office/drawing/2014/main" id="{060B7D9C-5072-4024-829A-40F240D5E98D}"/>
               </a:ext>
             </a:extLst>
           </p:cNvPr>
@@ -1670,7 +1670,7 @@
           <p:cNvPr id="2" name="Section title">
             <a:extLst xmlns:a="http://schemas.openxmlformats.org/drawingml/2006/main">
               <a:ext uri="{FF2B5EF4-FFF2-40B4-BE49-F238E27FC236}">
-                <a16:creationId xmlns:a16="http://schemas.microsoft.com/office/drawing/2014/main" id="{0EBF6B89-9252-4779-A0EC-4EED02958BCF}"/>
+                <a16:creationId xmlns:a16="http://schemas.microsoft.com/office/drawing/2014/main" id="{73322DD0-2CF6-492F-812A-86AE6FD32362}"/>
               </a:ext>
             </a:extLst>
           </p:cNvPr>
@@ -1916,7 +1916,7 @@
           <p:cNvPr id="3" name="Title">
             <a:extLst xmlns:a="http://schemas.openxmlformats.org/drawingml/2006/main">
               <a:ext uri="{FF2B5EF4-FFF2-40B4-BE49-F238E27FC236}">
-                <a16:creationId xmlns:a16="http://schemas.microsoft.com/office/drawing/2014/main" id="{ED66A787-1E05-488C-B56B-BF22382906EA}"/>
+                <a16:creationId xmlns:a16="http://schemas.microsoft.com/office/drawing/2014/main" id="{1A28BEB8-BBA3-43AF-9CD1-F97F583FA6D6}"/>
               </a:ext>
             </a:extLst>
           </p:cNvPr>
@@ -2145,7 +2145,7 @@
           <p:cNvPr id="2" name="Body">
             <a:extLst xmlns:a="http://schemas.openxmlformats.org/drawingml/2006/main">
               <a:ext uri="{FF2B5EF4-FFF2-40B4-BE49-F238E27FC236}">
-                <a16:creationId xmlns:a16="http://schemas.microsoft.com/office/drawing/2014/main" id="{67E271BE-75FD-4E8A-817D-EFDC9E7FBFA2}"/>
+                <a16:creationId xmlns:a16="http://schemas.microsoft.com/office/drawing/2014/main" id="{6E8186E6-5786-48D0-AF65-35C38187EE62}"/>
               </a:ext>
             </a:extLst>
           </p:cNvPr>
@@ -2391,7 +2391,7 @@
           <p:cNvPr id="4" name="Title">
             <a:extLst xmlns:a="http://schemas.openxmlformats.org/drawingml/2006/main">
               <a:ext uri="{FF2B5EF4-FFF2-40B4-BE49-F238E27FC236}">
-                <a16:creationId xmlns:a16="http://schemas.microsoft.com/office/drawing/2014/main" id="{AB752771-14E5-47ED-A7A6-C14401EAB04B}"/>
+                <a16:creationId xmlns:a16="http://schemas.microsoft.com/office/drawing/2014/main" id="{6089F401-8D58-457A-9FAF-675A4FD836DB}"/>
               </a:ext>
             </a:extLst>
           </p:cNvPr>
@@ -2620,7 +2620,7 @@
           <p:cNvPr id="2" name="Left column">
             <a:extLst xmlns:a="http://schemas.openxmlformats.org/drawingml/2006/main">
               <a:ext uri="{FF2B5EF4-FFF2-40B4-BE49-F238E27FC236}">
-                <a16:creationId xmlns:a16="http://schemas.microsoft.com/office/drawing/2014/main" id="{1551BD71-F240-4607-B928-085BED583CE1}"/>
+                <a16:creationId xmlns:a16="http://schemas.microsoft.com/office/drawing/2014/main" id="{F4E4DA3F-695C-414F-AE0A-BB53303539DF}"/>
               </a:ext>
             </a:extLst>
           </p:cNvPr>
@@ -2849,7 +2849,7 @@
           <p:cNvPr id="3" name="Right column">
             <a:extLst xmlns:a="http://schemas.openxmlformats.org/drawingml/2006/main">
               <a:ext uri="{FF2B5EF4-FFF2-40B4-BE49-F238E27FC236}">
-                <a16:creationId xmlns:a16="http://schemas.microsoft.com/office/drawing/2014/main" id="{9F90BEE5-7608-4727-8142-4DF0A8AD5A37}"/>
+                <a16:creationId xmlns:a16="http://schemas.microsoft.com/office/drawing/2014/main" id="{EA5D63C3-8FF2-4B00-B123-48D45D564A78}"/>
               </a:ext>
             </a:extLst>
           </p:cNvPr>
@@ -3095,7 +3095,7 @@
           <p:cNvPr id="3" name="Title">
             <a:extLst xmlns:a="http://schemas.openxmlformats.org/drawingml/2006/main">
               <a:ext uri="{FF2B5EF4-FFF2-40B4-BE49-F238E27FC236}">
-                <a16:creationId xmlns:a16="http://schemas.microsoft.com/office/drawing/2014/main" id="{63F74086-A12D-4A3B-8F34-F152086A0D1E}"/>
+                <a16:creationId xmlns:a16="http://schemas.microsoft.com/office/drawing/2014/main" id="{7955E58E-91AD-43E7-AD23-E2E8A4889F3F}"/>
               </a:ext>
             </a:extLst>
           </p:cNvPr>
@@ -3324,7 +3324,7 @@
           <p:cNvPr id="2" name="Left column">
             <a:extLst xmlns:a="http://schemas.openxmlformats.org/drawingml/2006/main">
               <a:ext uri="{FF2B5EF4-FFF2-40B4-BE49-F238E27FC236}">
-                <a16:creationId xmlns:a16="http://schemas.microsoft.com/office/drawing/2014/main" id="{4DF71820-5A29-498C-A73E-B11816F2C09B}"/>
+                <a16:creationId xmlns:a16="http://schemas.microsoft.com/office/drawing/2014/main" id="{49D1E001-3887-4429-80EA-41F67D05A98C}"/>
               </a:ext>
             </a:extLst>
           </p:cNvPr>
@@ -3591,12 +3591,12 @@
   </p:cSld>
   <p:clrMap bg1="lt1" tx1="dk1" bg2="lt2" tx2="dk2" accent1="accent1" accent2="accent2" accent3="accent3" accent4="accent4" accent5="accent5" accent6="accent6" hlink="hlink" folHlink="folHlink"/>
   <p:sldLayoutIdLst>
-    <p:sldLayoutId xmlns:r="http://schemas.openxmlformats.org/officeDocument/2006/relationships" id="2147483649" r:id="Rffd1911673ab4967"/>
-    <p:sldLayoutId xmlns:r="http://schemas.openxmlformats.org/officeDocument/2006/relationships" id="2147483650" r:id="Ra30f0ad61aba4391"/>
-    <p:sldLayoutId xmlns:r="http://schemas.openxmlformats.org/officeDocument/2006/relationships" id="2147483651" r:id="R34e8ac211fee4a59"/>
-    <p:sldLayoutId xmlns:r="http://schemas.openxmlformats.org/officeDocument/2006/relationships" id="2147483652" r:id="Raf5920c6bcd54d11"/>
-    <p:sldLayoutId xmlns:r="http://schemas.openxmlformats.org/officeDocument/2006/relationships" id="2147483653" r:id="R0fb8617c5653453d"/>
-    <p:sldLayoutId xmlns:r="http://schemas.openxmlformats.org/officeDocument/2006/relationships" id="2147483654" r:id="R2a4f09e6d8fe470a"/>
+    <p:sldLayoutId xmlns:r="http://schemas.openxmlformats.org/officeDocument/2006/relationships" id="2147483649" r:id="R8ec1f1515c8f404a"/>
+    <p:sldLayoutId xmlns:r="http://schemas.openxmlformats.org/officeDocument/2006/relationships" id="2147483650" r:id="Rd4cfcb3d24734df1"/>
+    <p:sldLayoutId xmlns:r="http://schemas.openxmlformats.org/officeDocument/2006/relationships" id="2147483651" r:id="R9a4866ea66bb4405"/>
+    <p:sldLayoutId xmlns:r="http://schemas.openxmlformats.org/officeDocument/2006/relationships" id="2147483652" r:id="Re417046307514cb8"/>
+    <p:sldLayoutId xmlns:r="http://schemas.openxmlformats.org/officeDocument/2006/relationships" id="2147483653" r:id="Rd1af418a077c43e2"/>
+    <p:sldLayoutId xmlns:r="http://schemas.openxmlformats.org/officeDocument/2006/relationships" id="2147483654" r:id="Rd60531ab64654264"/>
   </p:sldLayoutIdLst>
   <p:txStyles>
     <p:titleStyle>
@@ -4147,7 +4147,7 @@
           <p:cNvPr id="8" name="">
             <a:extLst xmlns:a="http://schemas.openxmlformats.org/drawingml/2006/main">
               <a:ext uri="{FF2B5EF4-FFF2-40B4-BE49-F238E27FC236}">
-                <a16:creationId xmlns:a16="http://schemas.microsoft.com/office/drawing/2014/main" id="{D40A5228-E448-4744-AAF3-06C961B510F3}"/>
+                <a16:creationId xmlns:a16="http://schemas.microsoft.com/office/drawing/2014/main" id="{51C47A8A-294B-46B4-85B3-B3579BB2EC2F}"/>
               </a:ext>
             </a:extLst>
           </p:cNvPr>
@@ -4303,7 +4303,7 @@
           <p:cNvPr id="2" name="">
             <a:extLst xmlns:a="http://schemas.openxmlformats.org/drawingml/2006/main">
               <a:ext uri="{FF2B5EF4-FFF2-40B4-BE49-F238E27FC236}">
-                <a16:creationId xmlns:a16="http://schemas.microsoft.com/office/drawing/2014/main" id="{56449707-70CA-4761-93C6-165F8E95E600}"/>
+                <a16:creationId xmlns:a16="http://schemas.microsoft.com/office/drawing/2014/main" id="{C4D86D34-EFEF-4DEF-95E2-F094E4ED1566}"/>
               </a:ext>
             </a:extLst>
           </p:cNvPr>
@@ -4459,7 +4459,7 @@
           <p:cNvPr id="3" name="">
             <a:extLst xmlns:a="http://schemas.openxmlformats.org/drawingml/2006/main">
               <a:ext uri="{FF2B5EF4-FFF2-40B4-BE49-F238E27FC236}">
-                <a16:creationId xmlns:a16="http://schemas.microsoft.com/office/drawing/2014/main" id="{0FAB2909-CF70-4F90-821D-7CD6694FAD6F}"/>
+                <a16:creationId xmlns:a16="http://schemas.microsoft.com/office/drawing/2014/main" id="{02986F1D-E66D-4133-A605-CA21DB8FB038}"/>
               </a:ext>
             </a:extLst>
           </p:cNvPr>
@@ -4615,7 +4615,7 @@
           <p:cNvPr id="4" name="">
             <a:extLst xmlns:a="http://schemas.openxmlformats.org/drawingml/2006/main">
               <a:ext uri="{FF2B5EF4-FFF2-40B4-BE49-F238E27FC236}">
-                <a16:creationId xmlns:a16="http://schemas.microsoft.com/office/drawing/2014/main" id="{4B88F860-6D3E-41A3-99F3-E2229DDB2A11}"/>
+                <a16:creationId xmlns:a16="http://schemas.microsoft.com/office/drawing/2014/main" id="{E1155198-2EA9-409A-9319-7C4F669B8449}"/>
               </a:ext>
             </a:extLst>
           </p:cNvPr>
@@ -4771,7 +4771,7 @@
           <p:cNvPr id="5" name="">
             <a:extLst xmlns:a="http://schemas.openxmlformats.org/drawingml/2006/main">
               <a:ext uri="{FF2B5EF4-FFF2-40B4-BE49-F238E27FC236}">
-                <a16:creationId xmlns:a16="http://schemas.microsoft.com/office/drawing/2014/main" id="{2F1E3C48-995D-4E72-AF4A-9C1101A84976}"/>
+                <a16:creationId xmlns:a16="http://schemas.microsoft.com/office/drawing/2014/main" id="{DA1D1E31-E9F1-4ECC-94A0-917F542733C6}"/>
               </a:ext>
             </a:extLst>
           </p:cNvPr>
@@ -4927,7 +4927,7 @@
           <p:cNvPr id="6" name="">
             <a:extLst xmlns:a="http://schemas.openxmlformats.org/drawingml/2006/main">
               <a:ext uri="{FF2B5EF4-FFF2-40B4-BE49-F238E27FC236}">
-                <a16:creationId xmlns:a16="http://schemas.microsoft.com/office/drawing/2014/main" id="{A557D875-AC93-48F8-891B-0A6F803F2CE0}"/>
+                <a16:creationId xmlns:a16="http://schemas.microsoft.com/office/drawing/2014/main" id="{E84482D3-FFAF-4D6B-A461-9EDE60B6AA57}"/>
               </a:ext>
             </a:extLst>
           </p:cNvPr>
@@ -5129,7 +5129,7 @@
           <p:cNvPr id="7" name="">
             <a:extLst xmlns:a="http://schemas.openxmlformats.org/drawingml/2006/main">
               <a:ext uri="{FF2B5EF4-FFF2-40B4-BE49-F238E27FC236}">
-                <a16:creationId xmlns:a16="http://schemas.microsoft.com/office/drawing/2014/main" id="{CC145D5D-2DC7-4C9B-9DC3-6CA784D54EF7}"/>
+                <a16:creationId xmlns:a16="http://schemas.microsoft.com/office/drawing/2014/main" id="{44AFE6C3-1D5A-4063-81E4-6BEE6E43B7B0}"/>
               </a:ext>
             </a:extLst>
           </p:cNvPr>
@@ -5283,7 +5283,7 @@
     </p:spTree>
     <p:extLst>
       <p:ext uri="{BB962C8B-B14F-4D97-AF65-F5344CB8AC3E}">
-        <p14:creationId xmlns:p14="http://schemas.microsoft.com/office/powerpoint/2010/main" val="526653703"/>
+        <p14:creationId xmlns:p14="http://schemas.microsoft.com/office/powerpoint/2010/main" val="2129520342"/>
       </p:ext>
     </p:extLst>
   </p:cSld>
@@ -5314,7 +5314,7 @@
           <p:cNvPr id="8" name="">
             <a:extLst xmlns:a="http://schemas.openxmlformats.org/drawingml/2006/main">
               <a:ext uri="{FF2B5EF4-FFF2-40B4-BE49-F238E27FC236}">
-                <a16:creationId xmlns:a16="http://schemas.microsoft.com/office/drawing/2014/main" id="{935CCCC6-CAD9-4C1C-8941-E725FD09B8B0}"/>
+                <a16:creationId xmlns:a16="http://schemas.microsoft.com/office/drawing/2014/main" id="{A305F203-DD1A-43D1-B640-E5334F698D89}"/>
               </a:ext>
             </a:extLst>
           </p:cNvPr>
@@ -5470,7 +5470,7 @@
           <p:cNvPr id="2" name="">
             <a:extLst xmlns:a="http://schemas.openxmlformats.org/drawingml/2006/main">
               <a:ext uri="{FF2B5EF4-FFF2-40B4-BE49-F238E27FC236}">
-                <a16:creationId xmlns:a16="http://schemas.microsoft.com/office/drawing/2014/main" id="{EA3EC72C-62EE-4CD3-AB20-C4AA63557D26}"/>
+                <a16:creationId xmlns:a16="http://schemas.microsoft.com/office/drawing/2014/main" id="{DDF19D3F-88A8-4A67-90B0-E8D5ECDD7291}"/>
               </a:ext>
             </a:extLst>
           </p:cNvPr>
@@ -5626,7 +5626,7 @@
           <p:cNvPr id="3" name="">
             <a:extLst xmlns:a="http://schemas.openxmlformats.org/drawingml/2006/main">
               <a:ext uri="{FF2B5EF4-FFF2-40B4-BE49-F238E27FC236}">
-                <a16:creationId xmlns:a16="http://schemas.microsoft.com/office/drawing/2014/main" id="{B26B25D2-F871-4AAB-9F12-9072BC079B85}"/>
+                <a16:creationId xmlns:a16="http://schemas.microsoft.com/office/drawing/2014/main" id="{8F15D050-CBB4-4A44-8638-17367E8B7504}"/>
               </a:ext>
             </a:extLst>
           </p:cNvPr>
@@ -5782,7 +5782,7 @@
           <p:cNvPr id="4" name="">
             <a:extLst xmlns:a="http://schemas.openxmlformats.org/drawingml/2006/main">
               <a:ext uri="{FF2B5EF4-FFF2-40B4-BE49-F238E27FC236}">
-                <a16:creationId xmlns:a16="http://schemas.microsoft.com/office/drawing/2014/main" id="{C31A14D8-C559-41AC-81DC-910C844BE2FE}"/>
+                <a16:creationId xmlns:a16="http://schemas.microsoft.com/office/drawing/2014/main" id="{B600E357-2FA1-47F7-A3DC-DA3372EDE223}"/>
               </a:ext>
             </a:extLst>
           </p:cNvPr>
@@ -5938,7 +5938,7 @@
           <p:cNvPr id="5" name="">
             <a:extLst xmlns:a="http://schemas.openxmlformats.org/drawingml/2006/main">
               <a:ext uri="{FF2B5EF4-FFF2-40B4-BE49-F238E27FC236}">
-                <a16:creationId xmlns:a16="http://schemas.microsoft.com/office/drawing/2014/main" id="{4EF66C2B-A1B8-47F9-B682-B6D6BE790DA6}"/>
+                <a16:creationId xmlns:a16="http://schemas.microsoft.com/office/drawing/2014/main" id="{EA026B03-1DC3-45BC-A5B4-3F1875C117C6}"/>
               </a:ext>
             </a:extLst>
           </p:cNvPr>
@@ -6094,7 +6094,7 @@
           <p:cNvPr id="6" name="">
             <a:extLst xmlns:a="http://schemas.openxmlformats.org/drawingml/2006/main">
               <a:ext uri="{FF2B5EF4-FFF2-40B4-BE49-F238E27FC236}">
-                <a16:creationId xmlns:a16="http://schemas.microsoft.com/office/drawing/2014/main" id="{71107DF3-8A94-40F1-8644-893229F7B651}"/>
+                <a16:creationId xmlns:a16="http://schemas.microsoft.com/office/drawing/2014/main" id="{EA4DCC3B-9C2F-43DA-8585-39B0529A50A0}"/>
               </a:ext>
             </a:extLst>
           </p:cNvPr>
@@ -6250,7 +6250,7 @@
           <p:cNvPr id="7" name="">
             <a:extLst xmlns:a="http://schemas.openxmlformats.org/drawingml/2006/main">
               <a:ext uri="{FF2B5EF4-FFF2-40B4-BE49-F238E27FC236}">
-                <a16:creationId xmlns:a16="http://schemas.microsoft.com/office/drawing/2014/main" id="{B105E779-322D-4140-9A0A-C130CDD3EF9A}"/>
+                <a16:creationId xmlns:a16="http://schemas.microsoft.com/office/drawing/2014/main" id="{3FC6E127-B6BE-4EB7-96E9-9CA87B7D2DA2}"/>
               </a:ext>
             </a:extLst>
           </p:cNvPr>
@@ -6404,7 +6404,7 @@
     </p:spTree>
     <p:extLst>
       <p:ext uri="{BB962C8B-B14F-4D97-AF65-F5344CB8AC3E}">
-        <p14:creationId xmlns:p14="http://schemas.microsoft.com/office/powerpoint/2010/main" val="895669157"/>
+        <p14:creationId xmlns:p14="http://schemas.microsoft.com/office/powerpoint/2010/main" val="1284674648"/>
       </p:ext>
     </p:extLst>
   </p:cSld>
@@ -6435,7 +6435,7 @@
           <p:cNvPr id="8" name="">
             <a:extLst xmlns:a="http://schemas.openxmlformats.org/drawingml/2006/main">
               <a:ext uri="{FF2B5EF4-FFF2-40B4-BE49-F238E27FC236}">
-                <a16:creationId xmlns:a16="http://schemas.microsoft.com/office/drawing/2014/main" id="{8C53BF02-6D29-4449-BD51-DA719D95709C}"/>
+                <a16:creationId xmlns:a16="http://schemas.microsoft.com/office/drawing/2014/main" id="{21D366DE-EC07-453B-BA80-05C6A536119A}"/>
               </a:ext>
             </a:extLst>
           </p:cNvPr>
@@ -6591,7 +6591,7 @@
           <p:cNvPr id="2" name="">
             <a:extLst xmlns:a="http://schemas.openxmlformats.org/drawingml/2006/main">
               <a:ext uri="{FF2B5EF4-FFF2-40B4-BE49-F238E27FC236}">
-                <a16:creationId xmlns:a16="http://schemas.microsoft.com/office/drawing/2014/main" id="{A14F2C54-3A00-4A3E-81BA-0AABAE6C2866}"/>
+                <a16:creationId xmlns:a16="http://schemas.microsoft.com/office/drawing/2014/main" id="{53EA3881-EB1D-4790-AFED-D3CCA26B117B}"/>
               </a:ext>
             </a:extLst>
           </p:cNvPr>
@@ -6747,7 +6747,7 @@
           <p:cNvPr id="3" name="">
             <a:extLst xmlns:a="http://schemas.openxmlformats.org/drawingml/2006/main">
               <a:ext uri="{FF2B5EF4-FFF2-40B4-BE49-F238E27FC236}">
-                <a16:creationId xmlns:a16="http://schemas.microsoft.com/office/drawing/2014/main" id="{CE14013D-9EEE-42D9-AF7F-BB005129B620}"/>
+                <a16:creationId xmlns:a16="http://schemas.microsoft.com/office/drawing/2014/main" id="{6D2D24E3-FD33-44EE-9591-9F4CCD9BB5E1}"/>
               </a:ext>
             </a:extLst>
           </p:cNvPr>
@@ -6903,7 +6903,7 @@
           <p:cNvPr id="4" name="">
             <a:extLst xmlns:a="http://schemas.openxmlformats.org/drawingml/2006/main">
               <a:ext uri="{FF2B5EF4-FFF2-40B4-BE49-F238E27FC236}">
-                <a16:creationId xmlns:a16="http://schemas.microsoft.com/office/drawing/2014/main" id="{94B881B3-29C6-4E57-B7D2-E3976FCCE6BB}"/>
+                <a16:creationId xmlns:a16="http://schemas.microsoft.com/office/drawing/2014/main" id="{B60C1CF4-132E-41ED-ADA1-E733D589E015}"/>
               </a:ext>
             </a:extLst>
           </p:cNvPr>
@@ -7059,7 +7059,7 @@
           <p:cNvPr id="5" name="">
             <a:extLst xmlns:a="http://schemas.openxmlformats.org/drawingml/2006/main">
               <a:ext uri="{FF2B5EF4-FFF2-40B4-BE49-F238E27FC236}">
-                <a16:creationId xmlns:a16="http://schemas.microsoft.com/office/drawing/2014/main" id="{E49951BA-BAA9-4C3C-8903-87148D5384DC}"/>
+                <a16:creationId xmlns:a16="http://schemas.microsoft.com/office/drawing/2014/main" id="{9597B4B6-E722-4E1E-95F8-9DD58B9EA3B2}"/>
               </a:ext>
             </a:extLst>
           </p:cNvPr>
@@ -7205,7 +7205,7 @@
                 <a:ea typeface="Arial"/>
                 <a:cs typeface="Arial"/>
               </a:rPr>
-              <a:t>Confirm the original Kaggle dataset and inherited artwork rights.</a:t>
+              <a:t>Retain the dataset attribution and confirm inherited artwork rights.</a:t>
             </a:r>
           </a:p>
         </p:txBody>
@@ -7215,7 +7215,7 @@
           <p:cNvPr id="6" name="">
             <a:extLst xmlns:a="http://schemas.openxmlformats.org/drawingml/2006/main">
               <a:ext uri="{FF2B5EF4-FFF2-40B4-BE49-F238E27FC236}">
-                <a16:creationId xmlns:a16="http://schemas.microsoft.com/office/drawing/2014/main" id="{5846BB2B-E669-4061-857F-1B2690B90F2F}"/>
+                <a16:creationId xmlns:a16="http://schemas.microsoft.com/office/drawing/2014/main" id="{2CEE42AE-81F4-4FF8-BEAF-B8C5E5FFA808}"/>
               </a:ext>
             </a:extLst>
           </p:cNvPr>
@@ -7371,7 +7371,7 @@
           <p:cNvPr id="7" name="">
             <a:extLst xmlns:a="http://schemas.openxmlformats.org/drawingml/2006/main">
               <a:ext uri="{FF2B5EF4-FFF2-40B4-BE49-F238E27FC236}">
-                <a16:creationId xmlns:a16="http://schemas.microsoft.com/office/drawing/2014/main" id="{6CDE4ECB-D4DF-42B6-96EE-75A06C2EB9FE}"/>
+                <a16:creationId xmlns:a16="http://schemas.microsoft.com/office/drawing/2014/main" id="{D541F595-5333-419A-8D06-FCC2A6B6EABD}"/>
               </a:ext>
             </a:extLst>
           </p:cNvPr>
@@ -7525,7 +7525,7 @@
     </p:spTree>
     <p:extLst>
       <p:ext uri="{BB962C8B-B14F-4D97-AF65-F5344CB8AC3E}">
-        <p14:creationId xmlns:p14="http://schemas.microsoft.com/office/powerpoint/2010/main" val="8986886"/>
+        <p14:creationId xmlns:p14="http://schemas.microsoft.com/office/powerpoint/2010/main" val="1516782346"/>
       </p:ext>
     </p:extLst>
   </p:cSld>
@@ -7556,7 +7556,7 @@
           <p:cNvPr id="8" name="">
             <a:extLst xmlns:a="http://schemas.openxmlformats.org/drawingml/2006/main">
               <a:ext uri="{FF2B5EF4-FFF2-40B4-BE49-F238E27FC236}">
-                <a16:creationId xmlns:a16="http://schemas.microsoft.com/office/drawing/2014/main" id="{B90B9265-8626-4ABD-8A07-59492FB44EE0}"/>
+                <a16:creationId xmlns:a16="http://schemas.microsoft.com/office/drawing/2014/main" id="{3FC74C10-D936-4447-91F9-98574E291DDD}"/>
               </a:ext>
             </a:extLst>
           </p:cNvPr>
@@ -7712,7 +7712,7 @@
           <p:cNvPr id="2" name="">
             <a:extLst xmlns:a="http://schemas.openxmlformats.org/drawingml/2006/main">
               <a:ext uri="{FF2B5EF4-FFF2-40B4-BE49-F238E27FC236}">
-                <a16:creationId xmlns:a16="http://schemas.microsoft.com/office/drawing/2014/main" id="{5265656C-979D-402A-AD3A-C5261C085A37}"/>
+                <a16:creationId xmlns:a16="http://schemas.microsoft.com/office/drawing/2014/main" id="{1AEFA808-E060-4AB6-8032-93AA2B863552}"/>
               </a:ext>
             </a:extLst>
           </p:cNvPr>
@@ -7868,7 +7868,7 @@
           <p:cNvPr id="3" name="">
             <a:extLst xmlns:a="http://schemas.openxmlformats.org/drawingml/2006/main">
               <a:ext uri="{FF2B5EF4-FFF2-40B4-BE49-F238E27FC236}">
-                <a16:creationId xmlns:a16="http://schemas.microsoft.com/office/drawing/2014/main" id="{0DC23E63-D30C-4B37-898D-C1A09E983E67}"/>
+                <a16:creationId xmlns:a16="http://schemas.microsoft.com/office/drawing/2014/main" id="{72B3677D-4CBA-496B-9B68-BDDBBE1BA4A8}"/>
               </a:ext>
             </a:extLst>
           </p:cNvPr>
@@ -8024,7 +8024,7 @@
           <p:cNvPr id="4" name="">
             <a:extLst xmlns:a="http://schemas.openxmlformats.org/drawingml/2006/main">
               <a:ext uri="{FF2B5EF4-FFF2-40B4-BE49-F238E27FC236}">
-                <a16:creationId xmlns:a16="http://schemas.microsoft.com/office/drawing/2014/main" id="{354DF46A-F63B-480B-9B9C-360441B93C66}"/>
+                <a16:creationId xmlns:a16="http://schemas.microsoft.com/office/drawing/2014/main" id="{FC56BDE3-AAC7-46D2-9F59-FC64B414D8C7}"/>
               </a:ext>
             </a:extLst>
           </p:cNvPr>
@@ -8180,7 +8180,7 @@
           <p:cNvPr id="5" name="">
             <a:extLst xmlns:a="http://schemas.openxmlformats.org/drawingml/2006/main">
               <a:ext uri="{FF2B5EF4-FFF2-40B4-BE49-F238E27FC236}">
-                <a16:creationId xmlns:a16="http://schemas.microsoft.com/office/drawing/2014/main" id="{4FB27C32-1734-4DFD-941F-B19FF3BA8FD4}"/>
+                <a16:creationId xmlns:a16="http://schemas.microsoft.com/office/drawing/2014/main" id="{AC46D49C-B11A-4E87-8598-E79E6DCA51A4}"/>
               </a:ext>
             </a:extLst>
           </p:cNvPr>
@@ -8336,7 +8336,7 @@
           <p:cNvPr id="6" name="">
             <a:extLst xmlns:a="http://schemas.openxmlformats.org/drawingml/2006/main">
               <a:ext uri="{FF2B5EF4-FFF2-40B4-BE49-F238E27FC236}">
-                <a16:creationId xmlns:a16="http://schemas.microsoft.com/office/drawing/2014/main" id="{16032D7B-A238-41E5-860B-2D9609D43906}"/>
+                <a16:creationId xmlns:a16="http://schemas.microsoft.com/office/drawing/2014/main" id="{06956355-4DDD-4C25-84D6-B4FCFF0534F7}"/>
               </a:ext>
             </a:extLst>
           </p:cNvPr>
@@ -8492,7 +8492,7 @@
           <p:cNvPr id="7" name="">
             <a:extLst xmlns:a="http://schemas.openxmlformats.org/drawingml/2006/main">
               <a:ext uri="{FF2B5EF4-FFF2-40B4-BE49-F238E27FC236}">
-                <a16:creationId xmlns:a16="http://schemas.microsoft.com/office/drawing/2014/main" id="{7CE049E4-9CD6-482D-A0ED-E5712ECE095D}"/>
+                <a16:creationId xmlns:a16="http://schemas.microsoft.com/office/drawing/2014/main" id="{65D1215C-A234-443C-9C41-25C00A522905}"/>
               </a:ext>
             </a:extLst>
           </p:cNvPr>
@@ -8646,7 +8646,7 @@
     </p:spTree>
     <p:extLst>
       <p:ext uri="{BB962C8B-B14F-4D97-AF65-F5344CB8AC3E}">
-        <p14:creationId xmlns:p14="http://schemas.microsoft.com/office/powerpoint/2010/main" val="837770954"/>
+        <p14:creationId xmlns:p14="http://schemas.microsoft.com/office/powerpoint/2010/main" val="1578019641"/>
       </p:ext>
     </p:extLst>
   </p:cSld>
@@ -8677,7 +8677,7 @@
           <p:cNvPr id="8" name="">
             <a:extLst xmlns:a="http://schemas.openxmlformats.org/drawingml/2006/main">
               <a:ext uri="{FF2B5EF4-FFF2-40B4-BE49-F238E27FC236}">
-                <a16:creationId xmlns:a16="http://schemas.microsoft.com/office/drawing/2014/main" id="{14510577-DAF0-4945-8D7F-CFA557137A65}"/>
+                <a16:creationId xmlns:a16="http://schemas.microsoft.com/office/drawing/2014/main" id="{833536A4-C29B-462F-9EB3-EE7FD20B57F2}"/>
               </a:ext>
             </a:extLst>
           </p:cNvPr>
@@ -8833,7 +8833,7 @@
           <p:cNvPr id="2" name="">
             <a:extLst xmlns:a="http://schemas.openxmlformats.org/drawingml/2006/main">
               <a:ext uri="{FF2B5EF4-FFF2-40B4-BE49-F238E27FC236}">
-                <a16:creationId xmlns:a16="http://schemas.microsoft.com/office/drawing/2014/main" id="{0E27CF3E-AC03-4F4C-BE7D-6DDE5CD33352}"/>
+                <a16:creationId xmlns:a16="http://schemas.microsoft.com/office/drawing/2014/main" id="{DC01DB7E-8380-416E-A588-BA1BFB13BBAE}"/>
               </a:ext>
             </a:extLst>
           </p:cNvPr>
@@ -8989,7 +8989,7 @@
           <p:cNvPr id="3" name="">
             <a:extLst xmlns:a="http://schemas.openxmlformats.org/drawingml/2006/main">
               <a:ext uri="{FF2B5EF4-FFF2-40B4-BE49-F238E27FC236}">
-                <a16:creationId xmlns:a16="http://schemas.microsoft.com/office/drawing/2014/main" id="{33A93EED-181E-49CC-B743-C295FC36C5FB}"/>
+                <a16:creationId xmlns:a16="http://schemas.microsoft.com/office/drawing/2014/main" id="{E04EC321-741F-45AB-8235-80A2EFAACE06}"/>
               </a:ext>
             </a:extLst>
           </p:cNvPr>
@@ -9145,7 +9145,7 @@
           <p:cNvPr id="4" name="">
             <a:extLst xmlns:a="http://schemas.openxmlformats.org/drawingml/2006/main">
               <a:ext uri="{FF2B5EF4-FFF2-40B4-BE49-F238E27FC236}">
-                <a16:creationId xmlns:a16="http://schemas.microsoft.com/office/drawing/2014/main" id="{DE952228-2C13-40BE-A368-D02136883080}"/>
+                <a16:creationId xmlns:a16="http://schemas.microsoft.com/office/drawing/2014/main" id="{F5B0F134-4790-4276-9026-909A7383EED4}"/>
               </a:ext>
             </a:extLst>
           </p:cNvPr>
@@ -9301,7 +9301,7 @@
           <p:cNvPr id="5" name="">
             <a:extLst xmlns:a="http://schemas.openxmlformats.org/drawingml/2006/main">
               <a:ext uri="{FF2B5EF4-FFF2-40B4-BE49-F238E27FC236}">
-                <a16:creationId xmlns:a16="http://schemas.microsoft.com/office/drawing/2014/main" id="{7B2E1362-3961-430C-98D4-BDAFFDCB645E}"/>
+                <a16:creationId xmlns:a16="http://schemas.microsoft.com/office/drawing/2014/main" id="{50E1E0E4-DBFA-4D4B-845F-4EDD51A96198}"/>
               </a:ext>
             </a:extLst>
           </p:cNvPr>
@@ -9457,7 +9457,7 @@
           <p:cNvPr id="6" name="">
             <a:extLst xmlns:a="http://schemas.openxmlformats.org/drawingml/2006/main">
               <a:ext uri="{FF2B5EF4-FFF2-40B4-BE49-F238E27FC236}">
-                <a16:creationId xmlns:a16="http://schemas.microsoft.com/office/drawing/2014/main" id="{3B272404-FB64-470F-8A34-0C463E7A81EE}"/>
+                <a16:creationId xmlns:a16="http://schemas.microsoft.com/office/drawing/2014/main" id="{78F79A9D-F431-4072-B40D-F38D90EF0397}"/>
               </a:ext>
             </a:extLst>
           </p:cNvPr>
@@ -9613,7 +9613,7 @@
           <p:cNvPr id="7" name="">
             <a:extLst xmlns:a="http://schemas.openxmlformats.org/drawingml/2006/main">
               <a:ext uri="{FF2B5EF4-FFF2-40B4-BE49-F238E27FC236}">
-                <a16:creationId xmlns:a16="http://schemas.microsoft.com/office/drawing/2014/main" id="{719E3762-C33C-4DA6-8FA1-B719ED32C791}"/>
+                <a16:creationId xmlns:a16="http://schemas.microsoft.com/office/drawing/2014/main" id="{0FF0D209-B04F-4008-A6EA-45CE1B70047A}"/>
               </a:ext>
             </a:extLst>
           </p:cNvPr>
@@ -9767,7 +9767,7 @@
     </p:spTree>
     <p:extLst>
       <p:ext uri="{BB962C8B-B14F-4D97-AF65-F5344CB8AC3E}">
-        <p14:creationId xmlns:p14="http://schemas.microsoft.com/office/powerpoint/2010/main" val="1069374241"/>
+        <p14:creationId xmlns:p14="http://schemas.microsoft.com/office/powerpoint/2010/main" val="2051981236"/>
       </p:ext>
     </p:extLst>
   </p:cSld>
@@ -9798,7 +9798,7 @@
           <p:cNvPr id="24" name="">
             <a:extLst xmlns:a="http://schemas.openxmlformats.org/drawingml/2006/main">
               <a:ext uri="{FF2B5EF4-FFF2-40B4-BE49-F238E27FC236}">
-                <a16:creationId xmlns:a16="http://schemas.microsoft.com/office/drawing/2014/main" id="{552219BC-6D6D-48C1-846D-98000807B119}"/>
+                <a16:creationId xmlns:a16="http://schemas.microsoft.com/office/drawing/2014/main" id="{D28FBFC5-D073-4685-A6C6-7A66E876937F}"/>
               </a:ext>
             </a:extLst>
           </p:cNvPr>
@@ -9954,7 +9954,7 @@
           <p:cNvPr id="2" name="">
             <a:extLst xmlns:a="http://schemas.openxmlformats.org/drawingml/2006/main">
               <a:ext uri="{FF2B5EF4-FFF2-40B4-BE49-F238E27FC236}">
-                <a16:creationId xmlns:a16="http://schemas.microsoft.com/office/drawing/2014/main" id="{999D11DB-FF8A-42B2-87CA-C243BEF0D961}"/>
+                <a16:creationId xmlns:a16="http://schemas.microsoft.com/office/drawing/2014/main" id="{D2610481-2D56-4C91-A0D1-65D330950690}"/>
               </a:ext>
             </a:extLst>
           </p:cNvPr>
@@ -10110,7 +10110,7 @@
           <p:cNvPr id="3" name="">
             <a:extLst xmlns:a="http://schemas.openxmlformats.org/drawingml/2006/main">
               <a:ext uri="{FF2B5EF4-FFF2-40B4-BE49-F238E27FC236}">
-                <a16:creationId xmlns:a16="http://schemas.microsoft.com/office/drawing/2014/main" id="{0B756449-0D0F-4BF3-A756-50349FC2BA46}"/>
+                <a16:creationId xmlns:a16="http://schemas.microsoft.com/office/drawing/2014/main" id="{FD4B5C35-E71A-4B05-B4C7-1417CD38D2BF}"/>
               </a:ext>
             </a:extLst>
           </p:cNvPr>
@@ -10266,7 +10266,7 @@
           <p:cNvPr id="4" name="">
             <a:extLst xmlns:a="http://schemas.openxmlformats.org/drawingml/2006/main">
               <a:ext uri="{FF2B5EF4-FFF2-40B4-BE49-F238E27FC236}">
-                <a16:creationId xmlns:a16="http://schemas.microsoft.com/office/drawing/2014/main" id="{2318D500-B60C-42AB-91B4-F3E3EFF3E67D}"/>
+                <a16:creationId xmlns:a16="http://schemas.microsoft.com/office/drawing/2014/main" id="{F7DC91F8-5B91-4DCC-8708-505CCF6B1B44}"/>
               </a:ext>
             </a:extLst>
           </p:cNvPr>
@@ -10298,7 +10298,7 @@
           <p:cNvPr id="5" name="">
             <a:extLst xmlns:a="http://schemas.openxmlformats.org/drawingml/2006/main">
               <a:ext uri="{FF2B5EF4-FFF2-40B4-BE49-F238E27FC236}">
-                <a16:creationId xmlns:a16="http://schemas.microsoft.com/office/drawing/2014/main" id="{397679BF-8425-4B6B-AE21-F2836F878382}"/>
+                <a16:creationId xmlns:a16="http://schemas.microsoft.com/office/drawing/2014/main" id="{7B66E87B-38AC-467C-8E75-FCFDC79BA86D}"/>
               </a:ext>
             </a:extLst>
           </p:cNvPr>
@@ -10477,7 +10477,7 @@
           <p:cNvPr id="6" name="">
             <a:extLst xmlns:a="http://schemas.openxmlformats.org/drawingml/2006/main">
               <a:ext uri="{FF2B5EF4-FFF2-40B4-BE49-F238E27FC236}">
-                <a16:creationId xmlns:a16="http://schemas.microsoft.com/office/drawing/2014/main" id="{D88A87D7-F5F2-4229-994D-529D86DE3B13}"/>
+                <a16:creationId xmlns:a16="http://schemas.microsoft.com/office/drawing/2014/main" id="{59A844D2-DE62-400F-BD7B-56D9907D336D}"/>
               </a:ext>
             </a:extLst>
           </p:cNvPr>
@@ -10509,7 +10509,7 @@
           <p:cNvPr id="7" name="">
             <a:extLst xmlns:a="http://schemas.openxmlformats.org/drawingml/2006/main">
               <a:ext uri="{FF2B5EF4-FFF2-40B4-BE49-F238E27FC236}">
-                <a16:creationId xmlns:a16="http://schemas.microsoft.com/office/drawing/2014/main" id="{D918AD1D-ABCC-4E57-BBA1-9C7F8B112D64}"/>
+                <a16:creationId xmlns:a16="http://schemas.microsoft.com/office/drawing/2014/main" id="{B2FEBE9B-A701-4918-A3C5-2EC5C3C38BFA}"/>
               </a:ext>
             </a:extLst>
           </p:cNvPr>
@@ -10688,7 +10688,7 @@
           <p:cNvPr id="8" name="">
             <a:extLst xmlns:a="http://schemas.openxmlformats.org/drawingml/2006/main">
               <a:ext uri="{FF2B5EF4-FFF2-40B4-BE49-F238E27FC236}">
-                <a16:creationId xmlns:a16="http://schemas.microsoft.com/office/drawing/2014/main" id="{9725BB32-FC08-4DEA-9DD7-4DEA22DCC60D}"/>
+                <a16:creationId xmlns:a16="http://schemas.microsoft.com/office/drawing/2014/main" id="{57251861-690E-4620-A9B0-3A91807E2A4B}"/>
               </a:ext>
             </a:extLst>
           </p:cNvPr>
@@ -10720,7 +10720,7 @@
           <p:cNvPr id="9" name="">
             <a:extLst xmlns:a="http://schemas.openxmlformats.org/drawingml/2006/main">
               <a:ext uri="{FF2B5EF4-FFF2-40B4-BE49-F238E27FC236}">
-                <a16:creationId xmlns:a16="http://schemas.microsoft.com/office/drawing/2014/main" id="{112BF99A-A31B-4582-B21D-B4E037D775A3}"/>
+                <a16:creationId xmlns:a16="http://schemas.microsoft.com/office/drawing/2014/main" id="{CA298842-5A2E-4327-8F89-C868BB38412A}"/>
               </a:ext>
             </a:extLst>
           </p:cNvPr>
@@ -10899,7 +10899,7 @@
           <p:cNvPr id="10" name="">
             <a:extLst xmlns:a="http://schemas.openxmlformats.org/drawingml/2006/main">
               <a:ext uri="{FF2B5EF4-FFF2-40B4-BE49-F238E27FC236}">
-                <a16:creationId xmlns:a16="http://schemas.microsoft.com/office/drawing/2014/main" id="{7DCB6E26-A6E8-4D71-960D-CDCA93B8CB6E}"/>
+                <a16:creationId xmlns:a16="http://schemas.microsoft.com/office/drawing/2014/main" id="{2F0FE5E2-7E4D-4BE0-B96C-690CD45B99C4}"/>
               </a:ext>
             </a:extLst>
           </p:cNvPr>
@@ -10931,7 +10931,7 @@
           <p:cNvPr id="11" name="">
             <a:extLst xmlns:a="http://schemas.openxmlformats.org/drawingml/2006/main">
               <a:ext uri="{FF2B5EF4-FFF2-40B4-BE49-F238E27FC236}">
-                <a16:creationId xmlns:a16="http://schemas.microsoft.com/office/drawing/2014/main" id="{06D05B0B-EFA1-4114-87D6-6EB02779F67C}"/>
+                <a16:creationId xmlns:a16="http://schemas.microsoft.com/office/drawing/2014/main" id="{BDC7E2EB-8633-4735-BBE6-AB88BED52AE2}"/>
               </a:ext>
             </a:extLst>
           </p:cNvPr>
@@ -11110,7 +11110,7 @@
           <p:cNvPr id="12" name="">
             <a:extLst xmlns:a="http://schemas.openxmlformats.org/drawingml/2006/main">
               <a:ext uri="{FF2B5EF4-FFF2-40B4-BE49-F238E27FC236}">
-                <a16:creationId xmlns:a16="http://schemas.microsoft.com/office/drawing/2014/main" id="{EA4E1CCB-BD29-4CA4-9BA9-908DBA4E1A61}"/>
+                <a16:creationId xmlns:a16="http://schemas.microsoft.com/office/drawing/2014/main" id="{E9A426A5-B01D-4165-B304-70B916FDF2DC}"/>
               </a:ext>
             </a:extLst>
           </p:cNvPr>
@@ -11142,7 +11142,7 @@
           <p:cNvPr id="13" name="">
             <a:extLst xmlns:a="http://schemas.openxmlformats.org/drawingml/2006/main">
               <a:ext uri="{FF2B5EF4-FFF2-40B4-BE49-F238E27FC236}">
-                <a16:creationId xmlns:a16="http://schemas.microsoft.com/office/drawing/2014/main" id="{E4EF29C0-E3AC-41C3-B4EC-82435733BD29}"/>
+                <a16:creationId xmlns:a16="http://schemas.microsoft.com/office/drawing/2014/main" id="{C8B42A3C-80E2-4082-AA44-CE09B4C7655A}"/>
               </a:ext>
             </a:extLst>
           </p:cNvPr>
@@ -11321,7 +11321,7 @@
           <p:cNvPr id="14" name="">
             <a:extLst xmlns:a="http://schemas.openxmlformats.org/drawingml/2006/main">
               <a:ext uri="{FF2B5EF4-FFF2-40B4-BE49-F238E27FC236}">
-                <a16:creationId xmlns:a16="http://schemas.microsoft.com/office/drawing/2014/main" id="{E3A72CBE-19E1-4693-9032-99729DEEACFF}"/>
+                <a16:creationId xmlns:a16="http://schemas.microsoft.com/office/drawing/2014/main" id="{297376E4-9218-42FE-AC4F-CBC1F83A3439}"/>
               </a:ext>
             </a:extLst>
           </p:cNvPr>
@@ -11353,7 +11353,7 @@
           <p:cNvPr id="15" name="">
             <a:extLst xmlns:a="http://schemas.openxmlformats.org/drawingml/2006/main">
               <a:ext uri="{FF2B5EF4-FFF2-40B4-BE49-F238E27FC236}">
-                <a16:creationId xmlns:a16="http://schemas.microsoft.com/office/drawing/2014/main" id="{9353FE85-9106-498F-8596-943DFBF90C15}"/>
+                <a16:creationId xmlns:a16="http://schemas.microsoft.com/office/drawing/2014/main" id="{B064E129-7883-4FE3-8102-6049D2B3EFE6}"/>
               </a:ext>
             </a:extLst>
           </p:cNvPr>
@@ -11532,7 +11532,7 @@
           <p:cNvPr id="16" name="">
             <a:extLst xmlns:a="http://schemas.openxmlformats.org/drawingml/2006/main">
               <a:ext uri="{FF2B5EF4-FFF2-40B4-BE49-F238E27FC236}">
-                <a16:creationId xmlns:a16="http://schemas.microsoft.com/office/drawing/2014/main" id="{E6CDABF5-D9D1-4A94-9AF2-605A30705436}"/>
+                <a16:creationId xmlns:a16="http://schemas.microsoft.com/office/drawing/2014/main" id="{AC59D2A5-EC05-412A-A3D6-1588C8F84FE6}"/>
               </a:ext>
             </a:extLst>
           </p:cNvPr>
@@ -11562,7 +11562,7 @@
           <p:cNvPr id="17" name="">
             <a:extLst xmlns:a="http://schemas.openxmlformats.org/drawingml/2006/main">
               <a:ext uri="{FF2B5EF4-FFF2-40B4-BE49-F238E27FC236}">
-                <a16:creationId xmlns:a16="http://schemas.microsoft.com/office/drawing/2014/main" id="{45E08AEA-D32B-4CC6-A69F-E0D16273F7D4}"/>
+                <a16:creationId xmlns:a16="http://schemas.microsoft.com/office/drawing/2014/main" id="{377CB050-AA48-4738-BC37-096CF2D0EEDA}"/>
               </a:ext>
             </a:extLst>
           </p:cNvPr>
@@ -11592,7 +11592,7 @@
           <p:cNvPr id="18" name="">
             <a:extLst xmlns:a="http://schemas.openxmlformats.org/drawingml/2006/main">
               <a:ext uri="{FF2B5EF4-FFF2-40B4-BE49-F238E27FC236}">
-                <a16:creationId xmlns:a16="http://schemas.microsoft.com/office/drawing/2014/main" id="{0749F262-6A94-48A0-B447-CAF1F8020000}"/>
+                <a16:creationId xmlns:a16="http://schemas.microsoft.com/office/drawing/2014/main" id="{2F626167-BB53-4476-9F8C-8C46FCC88767}"/>
               </a:ext>
             </a:extLst>
           </p:cNvPr>
@@ -11622,7 +11622,7 @@
           <p:cNvPr id="19" name="">
             <a:extLst xmlns:a="http://schemas.openxmlformats.org/drawingml/2006/main">
               <a:ext uri="{FF2B5EF4-FFF2-40B4-BE49-F238E27FC236}">
-                <a16:creationId xmlns:a16="http://schemas.microsoft.com/office/drawing/2014/main" id="{10690CC9-C9FF-4C03-B810-E8E808315E6C}"/>
+                <a16:creationId xmlns:a16="http://schemas.microsoft.com/office/drawing/2014/main" id="{5F014719-4FB3-4E28-8381-49591C7FCF8E}"/>
               </a:ext>
             </a:extLst>
           </p:cNvPr>
@@ -11652,7 +11652,7 @@
           <p:cNvPr id="20" name="">
             <a:extLst xmlns:a="http://schemas.openxmlformats.org/drawingml/2006/main">
               <a:ext uri="{FF2B5EF4-FFF2-40B4-BE49-F238E27FC236}">
-                <a16:creationId xmlns:a16="http://schemas.microsoft.com/office/drawing/2014/main" id="{884563D4-FEF6-4B87-8CEF-2BD9FD7D2E78}"/>
+                <a16:creationId xmlns:a16="http://schemas.microsoft.com/office/drawing/2014/main" id="{E82B9B66-324C-48DB-AA7F-8DEBD87C025E}"/>
               </a:ext>
             </a:extLst>
           </p:cNvPr>
@@ -11682,7 +11682,7 @@
           <p:cNvPr id="21" name="">
             <a:extLst xmlns:a="http://schemas.openxmlformats.org/drawingml/2006/main">
               <a:ext uri="{FF2B5EF4-FFF2-40B4-BE49-F238E27FC236}">
-                <a16:creationId xmlns:a16="http://schemas.microsoft.com/office/drawing/2014/main" id="{2BE5AA0E-4EDA-4414-8535-2ECB16B71F39}"/>
+                <a16:creationId xmlns:a16="http://schemas.microsoft.com/office/drawing/2014/main" id="{71CAA09F-F2F4-4449-8921-BE086A84E06E}"/>
               </a:ext>
             </a:extLst>
           </p:cNvPr>
@@ -11712,7 +11712,7 @@
           <p:cNvPr id="22" name="">
             <a:extLst xmlns:a="http://schemas.openxmlformats.org/drawingml/2006/main">
               <a:ext uri="{FF2B5EF4-FFF2-40B4-BE49-F238E27FC236}">
-                <a16:creationId xmlns:a16="http://schemas.microsoft.com/office/drawing/2014/main" id="{40514E61-19D6-4DA8-AB71-90BAC60F309B}"/>
+                <a16:creationId xmlns:a16="http://schemas.microsoft.com/office/drawing/2014/main" id="{AA49B2D3-4D74-4EA1-ACD1-5AFF7BE5DD1C}"/>
               </a:ext>
             </a:extLst>
           </p:cNvPr>
@@ -11742,7 +11742,7 @@
           <p:cNvPr id="23" name="">
             <a:extLst xmlns:a="http://schemas.openxmlformats.org/drawingml/2006/main">
               <a:ext uri="{FF2B5EF4-FFF2-40B4-BE49-F238E27FC236}">
-                <a16:creationId xmlns:a16="http://schemas.microsoft.com/office/drawing/2014/main" id="{15A0AB0F-59DE-4228-A60E-59668CD7ECB4}"/>
+                <a16:creationId xmlns:a16="http://schemas.microsoft.com/office/drawing/2014/main" id="{E3362410-E042-4887-9642-8FAB520018B9}"/>
               </a:ext>
             </a:extLst>
           </p:cNvPr>
@@ -11896,7 +11896,7 @@
     </p:spTree>
     <p:extLst>
       <p:ext uri="{BB962C8B-B14F-4D97-AF65-F5344CB8AC3E}">
-        <p14:creationId xmlns:p14="http://schemas.microsoft.com/office/powerpoint/2010/main" val="732712779"/>
+        <p14:creationId xmlns:p14="http://schemas.microsoft.com/office/powerpoint/2010/main" val="2004791205"/>
       </p:ext>
     </p:extLst>
   </p:cSld>
@@ -11927,7 +11927,7 @@
           <p:cNvPr id="8" name="">
             <a:extLst xmlns:a="http://schemas.openxmlformats.org/drawingml/2006/main">
               <a:ext uri="{FF2B5EF4-FFF2-40B4-BE49-F238E27FC236}">
-                <a16:creationId xmlns:a16="http://schemas.microsoft.com/office/drawing/2014/main" id="{5F803E2C-6DB4-4F70-A415-8D73C076D583}"/>
+                <a16:creationId xmlns:a16="http://schemas.microsoft.com/office/drawing/2014/main" id="{55261240-5F32-492C-A1BE-AE1C8E31D354}"/>
               </a:ext>
             </a:extLst>
           </p:cNvPr>
@@ -12083,7 +12083,7 @@
           <p:cNvPr id="2" name="">
             <a:extLst xmlns:a="http://schemas.openxmlformats.org/drawingml/2006/main">
               <a:ext uri="{FF2B5EF4-FFF2-40B4-BE49-F238E27FC236}">
-                <a16:creationId xmlns:a16="http://schemas.microsoft.com/office/drawing/2014/main" id="{9CAF3907-A7C1-4172-94D2-EBF10413D295}"/>
+                <a16:creationId xmlns:a16="http://schemas.microsoft.com/office/drawing/2014/main" id="{21A84781-9841-48F4-BB16-FAC84DDC6563}"/>
               </a:ext>
             </a:extLst>
           </p:cNvPr>
@@ -12239,7 +12239,7 @@
           <p:cNvPr id="3" name="">
             <a:extLst xmlns:a="http://schemas.openxmlformats.org/drawingml/2006/main">
               <a:ext uri="{FF2B5EF4-FFF2-40B4-BE49-F238E27FC236}">
-                <a16:creationId xmlns:a16="http://schemas.microsoft.com/office/drawing/2014/main" id="{5E1827EC-A937-4977-8872-521E72500508}"/>
+                <a16:creationId xmlns:a16="http://schemas.microsoft.com/office/drawing/2014/main" id="{AD5FB152-74A6-4499-B5E9-75FFB5BFBC29}"/>
               </a:ext>
             </a:extLst>
           </p:cNvPr>
@@ -12395,7 +12395,7 @@
           <p:cNvPr id="4" name="">
             <a:extLst xmlns:a="http://schemas.openxmlformats.org/drawingml/2006/main">
               <a:ext uri="{FF2B5EF4-FFF2-40B4-BE49-F238E27FC236}">
-                <a16:creationId xmlns:a16="http://schemas.microsoft.com/office/drawing/2014/main" id="{B272B3BA-F2FB-448E-A01D-0D323994597B}"/>
+                <a16:creationId xmlns:a16="http://schemas.microsoft.com/office/drawing/2014/main" id="{10ABAA25-ED35-4BFD-9823-F9B3C1A7FF47}"/>
               </a:ext>
             </a:extLst>
           </p:cNvPr>
@@ -12551,7 +12551,7 @@
           <p:cNvPr id="5" name="">
             <a:extLst xmlns:a="http://schemas.openxmlformats.org/drawingml/2006/main">
               <a:ext uri="{FF2B5EF4-FFF2-40B4-BE49-F238E27FC236}">
-                <a16:creationId xmlns:a16="http://schemas.microsoft.com/office/drawing/2014/main" id="{2F0B73A2-9C62-4E0E-8D67-060E428FB11D}"/>
+                <a16:creationId xmlns:a16="http://schemas.microsoft.com/office/drawing/2014/main" id="{5DBF3E6B-89C8-4DCC-B59C-C3AE89488023}"/>
               </a:ext>
             </a:extLst>
           </p:cNvPr>
@@ -12707,7 +12707,7 @@
           <p:cNvPr id="6" name="">
             <a:extLst xmlns:a="http://schemas.openxmlformats.org/drawingml/2006/main">
               <a:ext uri="{FF2B5EF4-FFF2-40B4-BE49-F238E27FC236}">
-                <a16:creationId xmlns:a16="http://schemas.microsoft.com/office/drawing/2014/main" id="{946C26DD-CF66-4C5B-B5B1-04BF3521810E}"/>
+                <a16:creationId xmlns:a16="http://schemas.microsoft.com/office/drawing/2014/main" id="{1D252652-F399-4F67-A06D-B6AE3341C35D}"/>
               </a:ext>
             </a:extLst>
           </p:cNvPr>
@@ -12863,7 +12863,7 @@
           <p:cNvPr id="7" name="">
             <a:extLst xmlns:a="http://schemas.openxmlformats.org/drawingml/2006/main">
               <a:ext uri="{FF2B5EF4-FFF2-40B4-BE49-F238E27FC236}">
-                <a16:creationId xmlns:a16="http://schemas.microsoft.com/office/drawing/2014/main" id="{E604E75B-390E-4360-A740-17FBEE9C9B17}"/>
+                <a16:creationId xmlns:a16="http://schemas.microsoft.com/office/drawing/2014/main" id="{687EF6F2-DECB-4840-A0A1-32F2D7970F63}"/>
               </a:ext>
             </a:extLst>
           </p:cNvPr>
@@ -13017,7 +13017,7 @@
     </p:spTree>
     <p:extLst>
       <p:ext uri="{BB962C8B-B14F-4D97-AF65-F5344CB8AC3E}">
-        <p14:creationId xmlns:p14="http://schemas.microsoft.com/office/powerpoint/2010/main" val="978684764"/>
+        <p14:creationId xmlns:p14="http://schemas.microsoft.com/office/powerpoint/2010/main" val="1993575926"/>
       </p:ext>
     </p:extLst>
   </p:cSld>
@@ -13048,7 +13048,7 @@
           <p:cNvPr id="8" name="">
             <a:extLst xmlns:a="http://schemas.openxmlformats.org/drawingml/2006/main">
               <a:ext uri="{FF2B5EF4-FFF2-40B4-BE49-F238E27FC236}">
-                <a16:creationId xmlns:a16="http://schemas.microsoft.com/office/drawing/2014/main" id="{ED8CB262-F9A4-4CD7-A903-32C5636B8A7A}"/>
+                <a16:creationId xmlns:a16="http://schemas.microsoft.com/office/drawing/2014/main" id="{70254BB7-8AD8-49D0-9431-32FE4975909F}"/>
               </a:ext>
             </a:extLst>
           </p:cNvPr>
@@ -13204,7 +13204,7 @@
           <p:cNvPr id="2" name="">
             <a:extLst xmlns:a="http://schemas.openxmlformats.org/drawingml/2006/main">
               <a:ext uri="{FF2B5EF4-FFF2-40B4-BE49-F238E27FC236}">
-                <a16:creationId xmlns:a16="http://schemas.microsoft.com/office/drawing/2014/main" id="{097807E1-9CDA-4A45-A3A1-6C81F86E49DC}"/>
+                <a16:creationId xmlns:a16="http://schemas.microsoft.com/office/drawing/2014/main" id="{FF9D0BCB-9F9D-4B62-BA86-B0BA96D0304E}"/>
               </a:ext>
             </a:extLst>
           </p:cNvPr>
@@ -13360,7 +13360,7 @@
           <p:cNvPr id="3" name="">
             <a:extLst xmlns:a="http://schemas.openxmlformats.org/drawingml/2006/main">
               <a:ext uri="{FF2B5EF4-FFF2-40B4-BE49-F238E27FC236}">
-                <a16:creationId xmlns:a16="http://schemas.microsoft.com/office/drawing/2014/main" id="{B2A232FE-78F1-41CA-AE84-8DC26A0B087F}"/>
+                <a16:creationId xmlns:a16="http://schemas.microsoft.com/office/drawing/2014/main" id="{C6F0A61A-D7CD-42EC-AEFF-0055491A4BF0}"/>
               </a:ext>
             </a:extLst>
           </p:cNvPr>
@@ -13516,7 +13516,7 @@
           <p:cNvPr id="4" name="">
             <a:extLst xmlns:a="http://schemas.openxmlformats.org/drawingml/2006/main">
               <a:ext uri="{FF2B5EF4-FFF2-40B4-BE49-F238E27FC236}">
-                <a16:creationId xmlns:a16="http://schemas.microsoft.com/office/drawing/2014/main" id="{6C845253-9E92-4AB6-9919-9ADA8FD7CBB9}"/>
+                <a16:creationId xmlns:a16="http://schemas.microsoft.com/office/drawing/2014/main" id="{ECB183C9-5CF2-4F74-955A-DCA8E56E868B}"/>
               </a:ext>
             </a:extLst>
           </p:cNvPr>
@@ -13672,7 +13672,7 @@
           <p:cNvPr id="5" name="">
             <a:extLst xmlns:a="http://schemas.openxmlformats.org/drawingml/2006/main">
               <a:ext uri="{FF2B5EF4-FFF2-40B4-BE49-F238E27FC236}">
-                <a16:creationId xmlns:a16="http://schemas.microsoft.com/office/drawing/2014/main" id="{6C5EF283-389A-4FCE-A1EA-474F62006008}"/>
+                <a16:creationId xmlns:a16="http://schemas.microsoft.com/office/drawing/2014/main" id="{687384AC-4068-4C91-8BC5-2FB146C7218C}"/>
               </a:ext>
             </a:extLst>
           </p:cNvPr>
@@ -13828,7 +13828,7 @@
           <p:cNvPr id="6" name="">
             <a:extLst xmlns:a="http://schemas.openxmlformats.org/drawingml/2006/main">
               <a:ext uri="{FF2B5EF4-FFF2-40B4-BE49-F238E27FC236}">
-                <a16:creationId xmlns:a16="http://schemas.microsoft.com/office/drawing/2014/main" id="{524A0548-8517-437E-99F8-E451E6FC2F32}"/>
+                <a16:creationId xmlns:a16="http://schemas.microsoft.com/office/drawing/2014/main" id="{2172BCAD-6B7F-4FFA-AD0B-DEA4CD6C2A35}"/>
               </a:ext>
             </a:extLst>
           </p:cNvPr>
@@ -13984,7 +13984,7 @@
           <p:cNvPr id="7" name="">
             <a:extLst xmlns:a="http://schemas.openxmlformats.org/drawingml/2006/main">
               <a:ext uri="{FF2B5EF4-FFF2-40B4-BE49-F238E27FC236}">
-                <a16:creationId xmlns:a16="http://schemas.microsoft.com/office/drawing/2014/main" id="{DA453109-6C4F-4994-9566-6E60E035E52B}"/>
+                <a16:creationId xmlns:a16="http://schemas.microsoft.com/office/drawing/2014/main" id="{C52AFFAF-35E7-4E39-9D59-F2B419601F09}"/>
               </a:ext>
             </a:extLst>
           </p:cNvPr>
@@ -14138,7 +14138,7 @@
     </p:spTree>
     <p:extLst>
       <p:ext uri="{BB962C8B-B14F-4D97-AF65-F5344CB8AC3E}">
-        <p14:creationId xmlns:p14="http://schemas.microsoft.com/office/powerpoint/2010/main" val="801143932"/>
+        <p14:creationId xmlns:p14="http://schemas.microsoft.com/office/powerpoint/2010/main" val="2064115700"/>
       </p:ext>
     </p:extLst>
   </p:cSld>
@@ -14169,7 +14169,7 @@
           <p:cNvPr id="8" name="">
             <a:extLst xmlns:a="http://schemas.openxmlformats.org/drawingml/2006/main">
               <a:ext uri="{FF2B5EF4-FFF2-40B4-BE49-F238E27FC236}">
-                <a16:creationId xmlns:a16="http://schemas.microsoft.com/office/drawing/2014/main" id="{7C48BA45-0479-4F3E-9EDE-8044A12C60B2}"/>
+                <a16:creationId xmlns:a16="http://schemas.microsoft.com/office/drawing/2014/main" id="{8B626C95-AC9C-4960-ADC2-9C9DB4A1CD45}"/>
               </a:ext>
             </a:extLst>
           </p:cNvPr>
@@ -14325,7 +14325,7 @@
           <p:cNvPr id="2" name="">
             <a:extLst xmlns:a="http://schemas.openxmlformats.org/drawingml/2006/main">
               <a:ext uri="{FF2B5EF4-FFF2-40B4-BE49-F238E27FC236}">
-                <a16:creationId xmlns:a16="http://schemas.microsoft.com/office/drawing/2014/main" id="{2079E26B-DD99-449D-BD56-2BDF3924556C}"/>
+                <a16:creationId xmlns:a16="http://schemas.microsoft.com/office/drawing/2014/main" id="{0A37BEEC-3B15-466F-A6F1-F7732623F99F}"/>
               </a:ext>
             </a:extLst>
           </p:cNvPr>
@@ -14481,7 +14481,7 @@
           <p:cNvPr id="3" name="">
             <a:extLst xmlns:a="http://schemas.openxmlformats.org/drawingml/2006/main">
               <a:ext uri="{FF2B5EF4-FFF2-40B4-BE49-F238E27FC236}">
-                <a16:creationId xmlns:a16="http://schemas.microsoft.com/office/drawing/2014/main" id="{737C08EB-B2EB-45A3-829C-B115FE343101}"/>
+                <a16:creationId xmlns:a16="http://schemas.microsoft.com/office/drawing/2014/main" id="{046681E5-DDB7-48D3-93D8-41AEB6CB6F3F}"/>
               </a:ext>
             </a:extLst>
           </p:cNvPr>
@@ -14637,7 +14637,7 @@
           <p:cNvPr id="4" name="">
             <a:extLst xmlns:a="http://schemas.openxmlformats.org/drawingml/2006/main">
               <a:ext uri="{FF2B5EF4-FFF2-40B4-BE49-F238E27FC236}">
-                <a16:creationId xmlns:a16="http://schemas.microsoft.com/office/drawing/2014/main" id="{3747C6CF-47E8-41E6-8D20-E446917F943F}"/>
+                <a16:creationId xmlns:a16="http://schemas.microsoft.com/office/drawing/2014/main" id="{F0837F31-1B0D-4448-BBD3-3188CBF4FF90}"/>
               </a:ext>
             </a:extLst>
           </p:cNvPr>
@@ -14793,7 +14793,7 @@
           <p:cNvPr id="5" name="">
             <a:extLst xmlns:a="http://schemas.openxmlformats.org/drawingml/2006/main">
               <a:ext uri="{FF2B5EF4-FFF2-40B4-BE49-F238E27FC236}">
-                <a16:creationId xmlns:a16="http://schemas.microsoft.com/office/drawing/2014/main" id="{E08DEE20-BB2C-4E07-B227-580EE2896B37}"/>
+                <a16:creationId xmlns:a16="http://schemas.microsoft.com/office/drawing/2014/main" id="{22431FD1-8753-44FB-A03D-9A8EA9D24F94}"/>
               </a:ext>
             </a:extLst>
           </p:cNvPr>
@@ -14949,7 +14949,7 @@
           <p:cNvPr id="6" name="">
             <a:extLst xmlns:a="http://schemas.openxmlformats.org/drawingml/2006/main">
               <a:ext uri="{FF2B5EF4-FFF2-40B4-BE49-F238E27FC236}">
-                <a16:creationId xmlns:a16="http://schemas.microsoft.com/office/drawing/2014/main" id="{2E0083CD-3B91-4906-B0E5-B154E9B901B9}"/>
+                <a16:creationId xmlns:a16="http://schemas.microsoft.com/office/drawing/2014/main" id="{1658505F-AC02-4E29-B4F9-C0842EC16898}"/>
               </a:ext>
             </a:extLst>
           </p:cNvPr>
@@ -15105,7 +15105,7 @@
           <p:cNvPr id="7" name="">
             <a:extLst xmlns:a="http://schemas.openxmlformats.org/drawingml/2006/main">
               <a:ext uri="{FF2B5EF4-FFF2-40B4-BE49-F238E27FC236}">
-                <a16:creationId xmlns:a16="http://schemas.microsoft.com/office/drawing/2014/main" id="{2EC13616-8DE1-4018-8CF2-A15C8435D704}"/>
+                <a16:creationId xmlns:a16="http://schemas.microsoft.com/office/drawing/2014/main" id="{6CDC4ADB-D7CD-40C9-A584-C12914234597}"/>
               </a:ext>
             </a:extLst>
           </p:cNvPr>
@@ -15259,7 +15259,7 @@
     </p:spTree>
     <p:extLst>
       <p:ext uri="{BB962C8B-B14F-4D97-AF65-F5344CB8AC3E}">
-        <p14:creationId xmlns:p14="http://schemas.microsoft.com/office/powerpoint/2010/main" val="1261973436"/>
+        <p14:creationId xmlns:p14="http://schemas.microsoft.com/office/powerpoint/2010/main" val="1114370974"/>
       </p:ext>
     </p:extLst>
   </p:cSld>
@@ -15290,7 +15290,7 @@
           <p:cNvPr id="8" name="">
             <a:extLst xmlns:a="http://schemas.openxmlformats.org/drawingml/2006/main">
               <a:ext uri="{FF2B5EF4-FFF2-40B4-BE49-F238E27FC236}">
-                <a16:creationId xmlns:a16="http://schemas.microsoft.com/office/drawing/2014/main" id="{515583D4-B7BA-429F-9802-3446BD5480B2}"/>
+                <a16:creationId xmlns:a16="http://schemas.microsoft.com/office/drawing/2014/main" id="{68FF4173-CC6C-4C69-A224-9580EB026A0F}"/>
               </a:ext>
             </a:extLst>
           </p:cNvPr>
@@ -15446,7 +15446,7 @@
           <p:cNvPr id="2" name="">
             <a:extLst xmlns:a="http://schemas.openxmlformats.org/drawingml/2006/main">
               <a:ext uri="{FF2B5EF4-FFF2-40B4-BE49-F238E27FC236}">
-                <a16:creationId xmlns:a16="http://schemas.microsoft.com/office/drawing/2014/main" id="{0A13326D-7FA2-4BCE-8165-999706AEAA7E}"/>
+                <a16:creationId xmlns:a16="http://schemas.microsoft.com/office/drawing/2014/main" id="{9DD35C24-5616-4B43-8190-55C1998685B0}"/>
               </a:ext>
             </a:extLst>
           </p:cNvPr>
@@ -15602,7 +15602,7 @@
           <p:cNvPr id="3" name="">
             <a:extLst xmlns:a="http://schemas.openxmlformats.org/drawingml/2006/main">
               <a:ext uri="{FF2B5EF4-FFF2-40B4-BE49-F238E27FC236}">
-                <a16:creationId xmlns:a16="http://schemas.microsoft.com/office/drawing/2014/main" id="{5FE3EE19-EBA1-4403-84F3-A8301F34A23C}"/>
+                <a16:creationId xmlns:a16="http://schemas.microsoft.com/office/drawing/2014/main" id="{14D7D90C-7DAD-4BF1-A219-2B74DF6FF9B5}"/>
               </a:ext>
             </a:extLst>
           </p:cNvPr>
@@ -15758,7 +15758,7 @@
           <p:cNvPr id="4" name="">
             <a:extLst xmlns:a="http://schemas.openxmlformats.org/drawingml/2006/main">
               <a:ext uri="{FF2B5EF4-FFF2-40B4-BE49-F238E27FC236}">
-                <a16:creationId xmlns:a16="http://schemas.microsoft.com/office/drawing/2014/main" id="{490BA3AA-8D3F-4D86-BF5F-BEB8DB584796}"/>
+                <a16:creationId xmlns:a16="http://schemas.microsoft.com/office/drawing/2014/main" id="{8873CF66-3999-467E-AAAD-FCC69B74F4A2}"/>
               </a:ext>
             </a:extLst>
           </p:cNvPr>
@@ -15914,7 +15914,7 @@
           <p:cNvPr id="5" name="">
             <a:extLst xmlns:a="http://schemas.openxmlformats.org/drawingml/2006/main">
               <a:ext uri="{FF2B5EF4-FFF2-40B4-BE49-F238E27FC236}">
-                <a16:creationId xmlns:a16="http://schemas.microsoft.com/office/drawing/2014/main" id="{FF1F1165-3DE1-4709-9698-E2325CA7A3C2}"/>
+                <a16:creationId xmlns:a16="http://schemas.microsoft.com/office/drawing/2014/main" id="{B6001621-6143-4FC3-AD4F-008DBE7659BE}"/>
               </a:ext>
             </a:extLst>
           </p:cNvPr>
@@ -16070,7 +16070,7 @@
           <p:cNvPr id="6" name="">
             <a:extLst xmlns:a="http://schemas.openxmlformats.org/drawingml/2006/main">
               <a:ext uri="{FF2B5EF4-FFF2-40B4-BE49-F238E27FC236}">
-                <a16:creationId xmlns:a16="http://schemas.microsoft.com/office/drawing/2014/main" id="{1B9394D5-041A-4DE6-B46A-19A9B7389102}"/>
+                <a16:creationId xmlns:a16="http://schemas.microsoft.com/office/drawing/2014/main" id="{D9900023-386F-4CCB-AE87-DD4B25D9A683}"/>
               </a:ext>
             </a:extLst>
           </p:cNvPr>
@@ -16226,7 +16226,7 @@
           <p:cNvPr id="7" name="">
             <a:extLst xmlns:a="http://schemas.openxmlformats.org/drawingml/2006/main">
               <a:ext uri="{FF2B5EF4-FFF2-40B4-BE49-F238E27FC236}">
-                <a16:creationId xmlns:a16="http://schemas.microsoft.com/office/drawing/2014/main" id="{A04C2368-6C45-4455-81D5-1ACDD2A45129}"/>
+                <a16:creationId xmlns:a16="http://schemas.microsoft.com/office/drawing/2014/main" id="{47991B73-99B1-46E2-88A8-CD58C3D9D233}"/>
               </a:ext>
             </a:extLst>
           </p:cNvPr>
@@ -16380,7 +16380,7 @@
     </p:spTree>
     <p:extLst>
       <p:ext uri="{BB962C8B-B14F-4D97-AF65-F5344CB8AC3E}">
-        <p14:creationId xmlns:p14="http://schemas.microsoft.com/office/powerpoint/2010/main" val="1357417831"/>
+        <p14:creationId xmlns:p14="http://schemas.microsoft.com/office/powerpoint/2010/main" val="1932271507"/>
       </p:ext>
     </p:extLst>
   </p:cSld>
@@ -16411,7 +16411,7 @@
           <p:cNvPr id="8" name="">
             <a:extLst xmlns:a="http://schemas.openxmlformats.org/drawingml/2006/main">
               <a:ext uri="{FF2B5EF4-FFF2-40B4-BE49-F238E27FC236}">
-                <a16:creationId xmlns:a16="http://schemas.microsoft.com/office/drawing/2014/main" id="{11FC73BE-392F-47BB-9C09-804C876AB248}"/>
+                <a16:creationId xmlns:a16="http://schemas.microsoft.com/office/drawing/2014/main" id="{13B421F4-D64D-47FB-B8EA-2D221682CAB7}"/>
               </a:ext>
             </a:extLst>
           </p:cNvPr>
@@ -16567,7 +16567,7 @@
           <p:cNvPr id="2" name="">
             <a:extLst xmlns:a="http://schemas.openxmlformats.org/drawingml/2006/main">
               <a:ext uri="{FF2B5EF4-FFF2-40B4-BE49-F238E27FC236}">
-                <a16:creationId xmlns:a16="http://schemas.microsoft.com/office/drawing/2014/main" id="{FB136C2F-51B4-4E76-98EF-C609DAA12F90}"/>
+                <a16:creationId xmlns:a16="http://schemas.microsoft.com/office/drawing/2014/main" id="{FC8DDF02-76C2-4343-8229-7882F89AED68}"/>
               </a:ext>
             </a:extLst>
           </p:cNvPr>
@@ -16723,7 +16723,7 @@
           <p:cNvPr id="3" name="">
             <a:extLst xmlns:a="http://schemas.openxmlformats.org/drawingml/2006/main">
               <a:ext uri="{FF2B5EF4-FFF2-40B4-BE49-F238E27FC236}">
-                <a16:creationId xmlns:a16="http://schemas.microsoft.com/office/drawing/2014/main" id="{FA7E03CF-91FF-4896-AC89-D2C9D3C4E119}"/>
+                <a16:creationId xmlns:a16="http://schemas.microsoft.com/office/drawing/2014/main" id="{24E3E370-F59C-4479-9DD4-0F9729D09362}"/>
               </a:ext>
             </a:extLst>
           </p:cNvPr>
@@ -16879,7 +16879,7 @@
           <p:cNvPr id="4" name="">
             <a:extLst xmlns:a="http://schemas.openxmlformats.org/drawingml/2006/main">
               <a:ext uri="{FF2B5EF4-FFF2-40B4-BE49-F238E27FC236}">
-                <a16:creationId xmlns:a16="http://schemas.microsoft.com/office/drawing/2014/main" id="{2D359EAD-D2AB-44D5-A543-4A9785F1929D}"/>
+                <a16:creationId xmlns:a16="http://schemas.microsoft.com/office/drawing/2014/main" id="{B6A4E8C1-2D22-4CC3-A051-CD36017021FD}"/>
               </a:ext>
             </a:extLst>
           </p:cNvPr>
@@ -17035,7 +17035,7 @@
           <p:cNvPr id="5" name="">
             <a:extLst xmlns:a="http://schemas.openxmlformats.org/drawingml/2006/main">
               <a:ext uri="{FF2B5EF4-FFF2-40B4-BE49-F238E27FC236}">
-                <a16:creationId xmlns:a16="http://schemas.microsoft.com/office/drawing/2014/main" id="{59AB4238-7CBB-487A-9125-392C6B44C6B9}"/>
+                <a16:creationId xmlns:a16="http://schemas.microsoft.com/office/drawing/2014/main" id="{CEA75E13-C4CE-4A2A-8A82-9D0C3EF2DC1F}"/>
               </a:ext>
             </a:extLst>
           </p:cNvPr>
@@ -17191,7 +17191,7 @@
           <p:cNvPr id="6" name="">
             <a:extLst xmlns:a="http://schemas.openxmlformats.org/drawingml/2006/main">
               <a:ext uri="{FF2B5EF4-FFF2-40B4-BE49-F238E27FC236}">
-                <a16:creationId xmlns:a16="http://schemas.microsoft.com/office/drawing/2014/main" id="{92A2072E-2191-465E-B735-5A79FAB687E2}"/>
+                <a16:creationId xmlns:a16="http://schemas.microsoft.com/office/drawing/2014/main" id="{CE9B9ED4-C896-472D-B2B7-5D1EA92D525E}"/>
               </a:ext>
             </a:extLst>
           </p:cNvPr>
@@ -17347,7 +17347,7 @@
           <p:cNvPr id="7" name="">
             <a:extLst xmlns:a="http://schemas.openxmlformats.org/drawingml/2006/main">
               <a:ext uri="{FF2B5EF4-FFF2-40B4-BE49-F238E27FC236}">
-                <a16:creationId xmlns:a16="http://schemas.microsoft.com/office/drawing/2014/main" id="{70CF96E3-9234-42D1-9B87-27B0C51B9F26}"/>
+                <a16:creationId xmlns:a16="http://schemas.microsoft.com/office/drawing/2014/main" id="{75AC2594-0DC4-4F69-89F0-98A9D179804F}"/>
               </a:ext>
             </a:extLst>
           </p:cNvPr>
@@ -17493,7 +17493,7 @@
                 <a:ea typeface="Arial"/>
                 <a:cs typeface="Arial"/>
               </a:rPr>
-              <a:t>Dataset and inherited artwork attribution still require confirmation.</a:t>
+              <a:t>The dataset source and licence are verified. Artwork rights still need confirmation.</a:t>
             </a:r>
           </a:p>
         </p:txBody>
@@ -17501,7 +17501,7 @@
     </p:spTree>
     <p:extLst>
       <p:ext uri="{BB962C8B-B14F-4D97-AF65-F5344CB8AC3E}">
-        <p14:creationId xmlns:p14="http://schemas.microsoft.com/office/powerpoint/2010/main" val="915171930"/>
+        <p14:creationId xmlns:p14="http://schemas.microsoft.com/office/powerpoint/2010/main" val="322335300"/>
       </p:ext>
     </p:extLst>
   </p:cSld>

</xml_diff>